<commit_message>
docs: deixar explícito que LaTeX ainda não foi iniciado
Ajustes no PPT da reunião 15/jun para esclarecer o estado real
da escrita:

1. Tabela do plano de escrita (Semana 1):
   - 'Setup do ambiente + Capítulo 1' →
     'Estrutura no repositório + Capítulo 1 (Introdução)'
   - Footer adicionado: 'LaTeX ainda não iniciado: estrutura
     sendo organizada no projeto base do GitHub. Migração para
     o Overleaf após consolidação.'

2. Próximos passos imediatos — reordenados em 6 itens:
   #1 'Consolidar a estrutura no repositório do GitHub
        (ainda não iniciei o LaTeX)'
   #2 'Migrar para o Overleaf assim que a estrutura estiver
        estável'
   (e demais passos deslocados para posições 3-6)

3. Decisão a alinhar (#4): mais específica agora —
   'Há template institucional Unifesp/ICT no Overleaf ou
    seguimos com o padrão?'

Co-Authored-By: Claude Opus 4.7 <noreply@anthropic.com>
</commit_message>
<xml_diff>
--- a/docs/ativo/material_reuniao_orientador_2026-06-15.pptx
+++ b/docs/ativo/material_reuniao_orientador_2026-06-15.pptx
@@ -7539,7 +7539,7 @@
                             <a:srgbClr val="3D424E"/>
                           </a:solidFill>
                         </a:rPr>
-                        <a:t>Setup do ambiente + Capítulo 1 (Introdução)</a:t>
+                        <a:t>Estrutura no repositório + Capítulo 1 (Introdução)</a:t>
                       </a:r>
                     </a:p>
                   </a:txBody>
@@ -7855,6 +7855,41 @@
           </a:graphicData>
         </a:graphic>
       </p:graphicFrame>
+      <p:sp>
+        <p:nvSpPr>
+          <p:cNvPr id="5" name="TextBox 4"/>
+          <p:cNvSpPr txBox="1"/>
+          <p:nvPr/>
+        </p:nvSpPr>
+        <p:spPr>
+          <a:xfrm>
+            <a:off x="457200" y="6446520"/>
+            <a:ext cx="11430000" cy="365760"/>
+          </a:xfrm>
+          <a:prstGeom prst="rect">
+            <a:avLst/>
+          </a:prstGeom>
+          <a:noFill/>
+        </p:spPr>
+        <p:txBody>
+          <a:bodyPr wrap="none">
+            <a:spAutoFit/>
+          </a:bodyPr>
+          <a:lstStyle/>
+          <a:p>
+            <a:pPr>
+              <a:defRPr sz="1000" i="1">
+                <a:solidFill>
+                  <a:srgbClr val="707682"/>
+                </a:solidFill>
+              </a:defRPr>
+            </a:pPr>
+            <a:r>
+              <a:t>LaTeX ainda não iniciado: estrutura sendo organizada no projeto base do GitHub. Migração para o Overleaf após consolidação.</a:t>
+            </a:r>
+          </a:p>
+        </p:txBody>
+      </p:sp>
     </p:spTree>
   </p:cSld>
   <p:clrMapOvr>
@@ -8061,7 +8096,7 @@
                   <a:srgbClr val="3D424E"/>
                 </a:solidFill>
               </a:rPr>
-              <a:t>Há template institucional para a escrita ou seguimos com o padrão?</a:t>
+              <a:t>Há template institucional Unifesp/ICT no Overleaf ou seguimos com o padrão?</a:t>
             </a:r>
           </a:p>
           <a:p>
@@ -8249,7 +8284,7 @@
                   <a:srgbClr val="3D424E"/>
                 </a:solidFill>
               </a:rPr>
-              <a:t>Setup do ambiente de escrita com template institucional</a:t>
+              <a:t>Consolidar a estrutura no repositório do GitHub (ainda não iniciei o LaTeX)</a:t>
             </a:r>
           </a:p>
           <a:p>
@@ -8272,7 +8307,7 @@
                   <a:srgbClr val="3D424E"/>
                 </a:solidFill>
               </a:rPr>
-              <a:t>Consolidar bibliografia a partir das 101 fichas</a:t>
+              <a:t>Migrar para o Overleaf assim que a estrutura estiver estável</a:t>
             </a:r>
           </a:p>
           <a:p>
@@ -8295,7 +8330,7 @@
                   <a:srgbClr val="3D424E"/>
                 </a:solidFill>
               </a:rPr>
-              <a:t>Escrever Capítulo 1 (Introdução) usando a narrativa de abertura</a:t>
+              <a:t>Consolidar a bibliografia a partir das 101 fichas</a:t>
             </a:r>
           </a:p>
           <a:p>
@@ -8318,7 +8353,7 @@
                   <a:srgbClr val="3D424E"/>
                 </a:solidFill>
               </a:rPr>
-              <a:t>Incorporar as imagens já produzidas (pipeline FiLM, ConvNeXt-T, métricas de Hardt)</a:t>
+              <a:t>Escrever Capítulo 1 (Introdução) usando a narrativa de abertura</a:t>
             </a:r>
           </a:p>
           <a:p>
@@ -8334,6 +8369,29 @@
                 </a:solidFill>
               </a:rPr>
               <a:t>5.  </a:t>
+            </a:r>
+            <a:r>
+              <a:rPr sz="1600">
+                <a:solidFill>
+                  <a:srgbClr val="3D424E"/>
+                </a:solidFill>
+              </a:rPr>
+              <a:t>Incorporar as imagens já produzidas (pipeline FiLM, ConvNeXt-T, métricas de Hardt)</a:t>
+            </a:r>
+          </a:p>
+          <a:p>
+            <a:pPr>
+              <a:spcAft>
+                <a:spcPts val="800"/>
+              </a:spcAft>
+            </a:pPr>
+            <a:r>
+              <a:rPr sz="1600" b="1">
+                <a:solidFill>
+                  <a:srgbClr val="1F2A4E"/>
+                </a:solidFill>
+              </a:rPr>
+              <a:t>6.  </a:t>
             </a:r>
             <a:r>
               <a:rPr sz="1600">

</xml_diff>

<commit_message>
docs: 2 ajustes pontuais no PPT
1. Slide 4 (tabela de decisões) — decisão #6:
   Observação 'Escrita em andamento' → 'Estrutura sendo
   organizada — LaTeX ainda não iniciado'
   (Evita dar impressão errada de que a escrita já começou.)

2. Slide 'Decisões a alinhar hoje':
   Removida pergunta #4 sobre template Overleaf — já foi
   compartilhado pelo orientador, não é mais ponto a discutir.
   Lista reduzida de 6 para 5 perguntas.

Co-Authored-By: Claude Opus 4.7 <noreply@anthropic.com>
</commit_message>
<xml_diff>
--- a/docs/ativo/material_reuniao_orientador_2026-06-15.pptx
+++ b/docs/ativo/material_reuniao_orientador_2026-06-15.pptx
@@ -8096,7 +8096,7 @@
                   <a:srgbClr val="3D424E"/>
                 </a:solidFill>
               </a:rPr>
-              <a:t>Há template institucional Unifesp/ICT no Overleaf ou seguimos com o padrão?</a:t>
+              <a:t>Co-orientador — já podemos formalizar?</a:t>
             </a:r>
           </a:p>
           <a:p>
@@ -8112,29 +8112,6 @@
                 </a:solidFill>
               </a:rPr>
               <a:t>5.  </a:t>
-            </a:r>
-            <a:r>
-              <a:rPr sz="1600">
-                <a:solidFill>
-                  <a:srgbClr val="3D424E"/>
-                </a:solidFill>
-              </a:rPr>
-              <a:t>Co-orientador — já podemos formalizar?</a:t>
-            </a:r>
-          </a:p>
-          <a:p>
-            <a:pPr>
-              <a:spcAft>
-                <a:spcPts val="800"/>
-              </a:spcAft>
-            </a:pPr>
-            <a:r>
-              <a:rPr sz="1600" b="1">
-                <a:solidFill>
-                  <a:srgbClr val="1F2A4E"/>
-                </a:solidFill>
-              </a:rPr>
-              <a:t>6.  </a:t>
             </a:r>
             <a:r>
               <a:rPr sz="1600">
@@ -9364,7 +9341,7 @@
                             <a:srgbClr val="3D424E"/>
                           </a:solidFill>
                         </a:rPr>
-                        <a:t>Escrita em andamento</a:t>
+                        <a:t>Estrutura sendo organizada — LaTeX ainda não iniciado</a:t>
                       </a:r>
                     </a:p>
                   </a:txBody>

</xml_diff>